<commit_message>
Fix frontier to efficient upper branch; full-sentence deck; larger frontier slide figure
</commit_message>
<xml_diff>
--- a/presentation/deck.pptx
+++ b/presentation/deck.pptx
@@ -3266,76 +3266,61 @@
           <a:p>
             <a:pPr>
               <a:spcAft>
-                <a:spcPts val="1400"/>
+                <a:spcPts val="1600"/>
               </a:spcAft>
-              <a:defRPr sz="2000">
+              <a:defRPr sz="1900">
                 <a:solidFill>
                   <a:srgbClr val="333333"/>
                 </a:solidFill>
               </a:defRPr>
             </a:pPr>
             <a:r>
-              <a:t>Canadians hold ≈50% of equity in Canadian stocks (IMF, via Vanguard 2024)…</a:t>
+              <a:t>Canadian investors display one of the world's strongest equity home biases: they allocate roughly 50% of their equity portfolios to domestic stocks (IMF Coordinated Portfolio Investment Survey, via Vanguard 2024).</a:t>
             </a:r>
           </a:p>
           <a:p>
             <a:pPr>
               <a:spcAft>
-                <a:spcPts val="1400"/>
+                <a:spcPts val="1600"/>
               </a:spcAft>
-              <a:defRPr sz="2000">
+              <a:defRPr sz="1900">
                 <a:solidFill>
                   <a:srgbClr val="333333"/>
                 </a:solidFill>
               </a:defRPr>
             </a:pPr>
             <a:r>
-              <a:t>…yet Canada is only ≈3% of world market cap — a 15–18x overweight.</a:t>
+              <a:t>Yet Canada accounts for only about 3% of global market capitalization — an overweight of roughly 15 to 18 times.</a:t>
             </a:r>
           </a:p>
           <a:p>
             <a:pPr>
               <a:spcAft>
-                <a:spcPts val="1400"/>
+                <a:spcPts val="1600"/>
               </a:spcAft>
-              <a:defRPr sz="2000">
+              <a:defRPr sz="1900">
                 <a:solidFill>
                   <a:srgbClr val="333333"/>
                 </a:solidFill>
               </a:defRPr>
             </a:pPr>
             <a:r>
-              <a:t>Vanguard's minimum-variance analysis recommends just 30% domestic equity.</a:t>
+              <a:t>Vanguard's minimum-variance analysis, however, suggests Canadian investors should hold only about 30% in domestic equity.</a:t>
             </a:r>
           </a:p>
           <a:p>
             <a:pPr>
               <a:spcAft>
-                <a:spcPts val="1400"/>
+                <a:spcPts val="1600"/>
               </a:spcAft>
-              <a:defRPr sz="2000">
+              <a:defRPr sz="1900">
                 <a:solidFill>
                   <a:srgbClr val="333333"/>
                 </a:solidFill>
               </a:defRPr>
             </a:pPr>
             <a:r>
-              <a:t>Question: is the observed home bias mean-variance efficient?</a:t>
-            </a:r>
-          </a:p>
-          <a:p>
-            <a:pPr>
-              <a:spcAft>
-                <a:spcPts val="1400"/>
-              </a:spcAft>
-              <a:defRPr sz="2000">
-                <a:solidFill>
-                  <a:srgbClr val="333333"/>
-                </a:solidFill>
-              </a:defRPr>
-            </a:pPr>
-            <a:r>
-              <a:t>Approach: trace the long-only frontier over regional equities (in CAD) and see what domestic weight the optimizer chooses.</a:t>
+              <a:t>This project asks whether the observed home bias is actually mean-variance efficient. We trace the long-only efficient frontier over regional equity markets and see what domestic weight the optimizer chooses.</a:t>
             </a:r>
           </a:p>
         </p:txBody>
@@ -3396,7 +3381,7 @@
               </a:defRPr>
             </a:pPr>
             <a:r>
-              <a:t>Data &amp; universe</a:t>
+              <a:t>Data and universe</a:t>
             </a:r>
           </a:p>
         </p:txBody>
@@ -3425,76 +3410,61 @@
           <a:p>
             <a:pPr>
               <a:spcAft>
-                <a:spcPts val="1400"/>
+                <a:spcPts val="1600"/>
               </a:spcAft>
-              <a:defRPr sz="2000">
+              <a:defRPr sz="1900">
                 <a:solidFill>
                   <a:srgbClr val="333333"/>
                 </a:solidFill>
               </a:defRPr>
             </a:pPr>
             <a:r>
-              <a:t>Five regional equity ETFs, monthly total returns (Yahoo Finance, adjusted closes):</a:t>
+              <a:t>Our universe is five regional equity ETFs, measured in monthly total returns from Yahoo Finance adjusted closes, which reinvest distributions: XIU.TO for Canada, SPY for US large cap, IWM for US small cap, EFA for developed markets ex-North America, and EEM for emerging markets.</a:t>
             </a:r>
           </a:p>
           <a:p>
             <a:pPr>
               <a:spcAft>
-                <a:spcPts val="1400"/>
+                <a:spcPts val="1600"/>
               </a:spcAft>
-              <a:defRPr sz="2000">
+              <a:defRPr sz="1900">
                 <a:solidFill>
                   <a:srgbClr val="333333"/>
                 </a:solidFill>
               </a:defRPr>
             </a:pPr>
             <a:r>
-              <a:t>XIU.TO Canada  ·  SPY US large cap  ·  IWM US small cap  ·  EFA dev. ex-NA  ·  EEM emerging</a:t>
+              <a:t>Returns on the USD-denominated ETFs are converted to Canadian dollars each month-end using the USD/CAD spot rate, so the analysis is from the perspective of an unhedged Canadian investor.</a:t>
             </a:r>
           </a:p>
           <a:p>
             <a:pPr>
               <a:spcAft>
-                <a:spcPts val="1400"/>
+                <a:spcPts val="1600"/>
               </a:spcAft>
-              <a:defRPr sz="2000">
+              <a:defRPr sz="1900">
                 <a:solidFill>
                   <a:srgbClr val="333333"/>
                 </a:solidFill>
               </a:defRPr>
             </a:pPr>
             <a:r>
-              <a:t>USD series converted to CAD each month-end via USD/CAD (unhedged).</a:t>
+              <a:t>The sample runs from October 2003 to August 2026 — 275 monthly observations. Means are annualized by ×12 and covariances by ×12.</a:t>
             </a:r>
           </a:p>
           <a:p>
             <a:pPr>
               <a:spcAft>
-                <a:spcPts val="1400"/>
+                <a:spcPts val="1600"/>
               </a:spcAft>
-              <a:defRPr sz="2000">
+              <a:defRPr sz="1900">
                 <a:solidFill>
                   <a:srgbClr val="333333"/>
                 </a:solidFill>
               </a:defRPr>
             </a:pPr>
             <a:r>
-              <a:t>Sample: Oct 2003 – Aug 2026, 275 months. Means ×12, covariances ×12.</a:t>
-            </a:r>
-          </a:p>
-          <a:p>
-            <a:pPr>
-              <a:spcAft>
-                <a:spcPts val="1400"/>
-              </a:spcAft>
-              <a:defRPr sz="2000">
-                <a:solidFill>
-                  <a:srgbClr val="333333"/>
-                </a:solidFill>
-              </a:defRPr>
-            </a:pPr>
-            <a:r>
-              <a:t>Note: brief asks for CRSP/Compustat via WRDS (no access here); ETF total returns are the reproducible proxy — pipeline accepts a WRDS extract as drop-in.</a:t>
+              <a:t>One caveat: the brief asks for CRSP/Compustat data via WRDS, which we could not access. The ETF series are a documented, reproducible proxy, and the code accepts a WRDS extract as a drop-in replacement.</a:t>
             </a:r>
           </a:p>
         </p:txBody>
@@ -3584,76 +3554,61 @@
           <a:p>
             <a:pPr>
               <a:spcAft>
-                <a:spcPts val="1400"/>
+                <a:spcPts val="1600"/>
               </a:spcAft>
-              <a:defRPr sz="2000">
+              <a:defRPr sz="1900">
                 <a:solidFill>
                   <a:srgbClr val="333333"/>
                 </a:solidFill>
               </a:defRPr>
             </a:pPr>
             <a:r>
-              <a:t>Canada: mean 10.6%, vol 12.8% — lowest volatility of the five.</a:t>
+              <a:t>Canada offers the lowest volatility of the five markets at 12.8%, with a mean return of 10.6%.</a:t>
             </a:r>
           </a:p>
           <a:p>
             <a:pPr>
               <a:spcAft>
-                <a:spcPts val="1400"/>
+                <a:spcPts val="1600"/>
               </a:spcAft>
-              <a:defRPr sz="2000">
+              <a:defRPr sz="1900">
                 <a:solidFill>
                   <a:srgbClr val="333333"/>
                 </a:solidFill>
               </a:defRPr>
             </a:pPr>
             <a:r>
-              <a:t>US large cap: mean 12.5%, vol 16.9% — highest mean.</a:t>
+              <a:t>US large cap has the highest mean return at 12.5% with 16.9% volatility. US small cap (11.9% / 21.6%), developed ex-NA (9.3% / 18.4%), and emerging markets (11.2% / 22.3%) are all riskier.</a:t>
             </a:r>
           </a:p>
           <a:p>
             <a:pPr>
               <a:spcAft>
-                <a:spcPts val="1400"/>
+                <a:spcPts val="1600"/>
               </a:spcAft>
-              <a:defRPr sz="2000">
+              <a:defRPr sz="1900">
                 <a:solidFill>
                   <a:srgbClr val="333333"/>
                 </a:solidFill>
               </a:defRPr>
             </a:pPr>
             <a:r>
-              <a:t>US small cap 11.9% / 21.6%  ·  EAFE 9.3% / 18.4%  ·  Emerging 11.2% / 22.3%.</a:t>
+              <a:t>Correlations range from 0.67 to 0.90: Canada correlates about 0.68 with every other market, while US large and small caps correlate 0.90 and EAFE and emerging markets correlate 0.87.</a:t>
             </a:r>
           </a:p>
           <a:p>
             <a:pPr>
               <a:spcAft>
-                <a:spcPts val="1400"/>
+                <a:spcPts val="1600"/>
               </a:spcAft>
-              <a:defRPr sz="2000">
+              <a:defRPr sz="1900">
                 <a:solidFill>
                   <a:srgbClr val="333333"/>
                 </a:solidFill>
               </a:defRPr>
             </a:pPr>
             <a:r>
-              <a:t>Correlations 0.67–0.90: Canada ~0.68 with everyone; US large/small 0.90; EAFE/EM 0.87.</a:t>
-            </a:r>
-          </a:p>
-          <a:p>
-            <a:pPr>
-              <a:spcAft>
-                <a:spcPts val="1400"/>
-              </a:spcAft>
-              <a:defRPr sz="2000">
-                <a:solidFill>
-                  <a:srgbClr val="333333"/>
-                </a:solidFill>
-              </a:defRPr>
-            </a:pPr>
-            <a:r>
-              <a:t>High correlations → limited diversification benefit beyond 2 assets.</a:t>
+              <a:t>These high correlations limit the diversification benefit beyond a two-asset portfolio — a hint of why the optimizer will end up concentrating.</a:t>
             </a:r>
           </a:p>
         </p:txBody>
@@ -3714,7 +3669,7 @@
               </a:defRPr>
             </a:pPr>
             <a:r>
-              <a:t>Frontier &amp; selection criterion</a:t>
+              <a:t>Frontier and selection criterion</a:t>
             </a:r>
           </a:p>
         </p:txBody>
@@ -3728,7 +3683,7 @@
         <p:spPr>
           <a:xfrm>
             <a:off x="822960" y="1371600"/>
-            <a:ext cx="5120640" cy="5029200"/>
+            <a:ext cx="4480560" cy="5029200"/>
           </a:xfrm>
           <a:prstGeom prst="rect">
             <a:avLst/>
@@ -3743,68 +3698,53 @@
           <a:p>
             <a:pPr>
               <a:spcAft>
-                <a:spcPts val="1400"/>
+                <a:spcPts val="1600"/>
               </a:spcAft>
-              <a:defRPr sz="2000">
+              <a:defRPr sz="1900">
                 <a:solidFill>
                   <a:srgbClr val="333333"/>
                 </a:solidFill>
               </a:defRPr>
             </a:pPr>
             <a:r>
-              <a:t>Quadratic programs: min w′Σw s.t. w′μ = m*, Σw = 1, w ≥ 0 (long-only).</a:t>
+              <a:t>We solve min w′Σw subject to w′μ = m*, Σw = 1, w ≥ 0 for a grid of target returns — one quadratic program per point — tracing out the long-only efficient frontier shown here.</a:t>
             </a:r>
           </a:p>
           <a:p>
             <a:pPr>
               <a:spcAft>
-                <a:spcPts val="1400"/>
+                <a:spcPts val="1600"/>
               </a:spcAft>
-              <a:defRPr sz="2000">
+              <a:defRPr sz="1900">
                 <a:solidFill>
                   <a:srgbClr val="333333"/>
                 </a:solidFill>
               </a:defRPr>
             </a:pPr>
             <a:r>
-              <a:t>No risk-free asset → no tangency/Sharpe rule; we maximize mean-variance utility</a:t>
+              <a:t>With no risk-free asset there is no tangency portfolio or Sharpe-ratio rule, so we select the portfolio that maximizes mean-variance utility U = E[rp] − (γ/2)·Var[rp], with γ = 3 following the course convention.</a:t>
             </a:r>
           </a:p>
           <a:p>
             <a:pPr>
               <a:spcAft>
-                <a:spcPts val="1400"/>
+                <a:spcPts val="1600"/>
               </a:spcAft>
-              <a:defRPr sz="2000">
+              <a:defRPr sz="1900">
                 <a:solidFill>
                   <a:srgbClr val="333333"/>
                 </a:solidFill>
               </a:defRPr>
             </a:pPr>
             <a:r>
-              <a:t>U = E[rp] − (g/2)·Var[rp] with g = 3 (course convention; typical range 1–10).</a:t>
-            </a:r>
-          </a:p>
-          <a:p>
-            <a:pPr>
-              <a:spcAft>
-                <a:spcPts val="1400"/>
-              </a:spcAft>
-              <a:defRPr sz="2000">
-                <a:solidFill>
-                  <a:srgbClr val="333333"/>
-                </a:solidFill>
-              </a:defRPr>
-            </a:pPr>
-            <a:r>
-              <a:t>Long-only: the question is about a retail investor's strategic allocation.</a:t>
+              <a:t>The long-only constraint reflects the economic question: what would a retail investor's strategic equity allocation look like? It also keeps the answer interpretable.</a:t>
             </a:r>
           </a:p>
         </p:txBody>
       </p:sp>
       <p:pic>
         <p:nvPicPr>
-          <p:cNvPr id="4" name="Picture 3" descr="frontier.png"/>
+          <p:cNvPr id="4" name="Picture 3" descr="frontier_slide.png"/>
           <p:cNvPicPr>
             <a:picLocks noChangeAspect="1"/>
           </p:cNvPicPr>
@@ -3818,8 +3758,8 @@
         </p:blipFill>
         <p:spPr>
           <a:xfrm>
-            <a:off x="6309360" y="1371600"/>
-            <a:ext cx="5212080" cy="3583305"/>
+            <a:off x="5577840" y="1371600"/>
+            <a:ext cx="5943600" cy="4094480"/>
           </a:xfrm>
           <a:prstGeom prst="rect">
             <a:avLst/>
@@ -3911,61 +3851,61 @@
           <a:p>
             <a:pPr>
               <a:spcAft>
-                <a:spcPts val="1400"/>
+                <a:spcPts val="1600"/>
               </a:spcAft>
-              <a:defRPr sz="2000">
+              <a:defRPr sz="1900">
                 <a:solidFill>
                   <a:srgbClr val="333333"/>
                 </a:solidFill>
               </a:defRPr>
             </a:pPr>
             <a:r>
-              <a:t>Optimal (g = 3):  48% Canada / 52% US large cap — E[r] = 11.6%, σ = 13.7%.</a:t>
+              <a:t>At γ = 3, the optimizer holds 48% Canada and 52% US large cap, with an expected return of 11.6% and volatility of 13.7%.</a:t>
             </a:r>
           </a:p>
           <a:p>
             <a:pPr>
               <a:spcAft>
-                <a:spcPts val="1400"/>
+                <a:spcPts val="1600"/>
               </a:spcAft>
-              <a:defRPr sz="2000">
+              <a:defRPr sz="1900">
                 <a:solidFill>
                   <a:srgbClr val="333333"/>
                 </a:solidFill>
               </a:defRPr>
             </a:pPr>
             <a:r>
-              <a:t>US small cap, EAFE, emerging markets: 0% (corner solution — error maximization).</a:t>
+              <a:t>US small cap, developed ex-NA, and emerging markets receive zero weight — a corner solution typical of error-maximizing mean-variance optimizers facing highly correlated assets.</a:t>
             </a:r>
           </a:p>
           <a:p>
             <a:pPr>
               <a:spcAft>
-                <a:spcPts val="1400"/>
+                <a:spcPts val="1600"/>
               </a:spcAft>
-              <a:defRPr sz="2000">
+              <a:defRPr sz="1900">
                 <a:solidFill>
                   <a:srgbClr val="333333"/>
                 </a:solidFill>
               </a:defRPr>
             </a:pPr>
             <a:r>
-              <a:t>Sensitivity: optimal Canada weight is 28% (g=2) → 48% (g=3) → 64% (g=5).</a:t>
+              <a:t>The answer is sensitive to risk aversion: the optimal Canada weight rises from 28% at γ = 2 to 48% at γ = 3 and 64% at γ = 5.</a:t>
             </a:r>
           </a:p>
           <a:p>
             <a:pPr>
               <a:spcAft>
-                <a:spcPts val="1400"/>
+                <a:spcPts val="1600"/>
               </a:spcAft>
-              <a:defRPr sz="2000">
+              <a:defRPr sz="1900">
                 <a:solidFill>
                   <a:srgbClr val="333333"/>
                 </a:solidFill>
               </a:defRPr>
             </a:pPr>
             <a:r>
-              <a:t>Minimum-variance portfolio: 89% Canada / 11% US (E[r] = 10.8%, σ = 12.7%).</a:t>
+              <a:t>For reference, the minimum-variance portfolio is 89% Canada and 11% US large cap, with E[r] = 10.8% and σ = 12.7%.</a:t>
             </a:r>
           </a:p>
         </p:txBody>
@@ -4055,61 +3995,61 @@
           <a:p>
             <a:pPr>
               <a:spcAft>
-                <a:spcPts val="1400"/>
+                <a:spcPts val="1600"/>
               </a:spcAft>
-              <a:defRPr sz="2000">
+              <a:defRPr sz="1900">
                 <a:solidFill>
                   <a:srgbClr val="333333"/>
                 </a:solidFill>
               </a:defRPr>
             </a:pPr>
             <a:r>
-              <a:t>At g = 3 the optimizer chooses 48% domestic — essentially the ≈50% Canadians hold.</a:t>
+              <a:t>At γ = 3 the optimizer chooses 48% domestic equity — essentially the 50% that Canadians actually hold.</a:t>
             </a:r>
           </a:p>
           <a:p>
             <a:pPr>
               <a:spcAft>
-                <a:spcPts val="1400"/>
+                <a:spcPts val="1600"/>
               </a:spcAft>
-              <a:defRPr sz="2000">
+              <a:defRPr sz="1900">
                 <a:solidFill>
                   <a:srgbClr val="333333"/>
                 </a:solidFill>
               </a:defRPr>
             </a:pPr>
             <a:r>
-              <a:t>The home bias is roughly mean-variance efficient for moderate risk aversion, not the glaring inefficiency its 15–18x cap-weight overweight suggests.</a:t>
+              <a:t>The home bias is therefore roughly mean-variance efficient for a moderately risk-averse investor, not the glaring inefficiency its 15–18× market-cap overweight suggests.</a:t>
             </a:r>
           </a:p>
           <a:p>
             <a:pPr>
               <a:spcAft>
-                <a:spcPts val="1400"/>
+                <a:spcPts val="1600"/>
               </a:spcAft>
-              <a:defRPr sz="2000">
+              <a:defRPr sz="1900">
                 <a:solidFill>
                   <a:srgbClr val="333333"/>
                 </a:solidFill>
               </a:defRPr>
             </a:pPr>
             <a:r>
-              <a:t>Vanguard's 30% recommendation sits in the efficient zone too (implies g ≈ 4–5).</a:t>
+              <a:t>Vanguard's 30% recommendation sits inside the efficient zone too — it corresponds to a risk aversion of about γ = 4–5.</a:t>
             </a:r>
           </a:p>
           <a:p>
             <a:pPr>
               <a:spcAft>
-                <a:spcPts val="1400"/>
+                <a:spcPts val="1600"/>
               </a:spcAft>
-              <a:defRPr sz="2000">
+              <a:defRPr sz="1900">
                 <a:solidFill>
                   <a:srgbClr val="333333"/>
                 </a:solidFill>
               </a:defRPr>
             </a:pPr>
             <a:r>
-              <a:t>Caveats: extreme corner solution; min-variance implies 89% domestic; sample- and criterion-dependent; unhedged currency; taxes/fees ignored.</a:t>
+              <a:t>Caveats: the corner solution is extreme, the minimum-variance criterion implies 89% domestic, and the results depend on the sample, the criterion, unhedged currency — and ignore taxes and fees.</a:t>
             </a:r>
           </a:p>
         </p:txBody>
@@ -4199,24 +4139,24 @@
           <a:p>
             <a:pPr>
               <a:spcAft>
-                <a:spcPts val="1400"/>
+                <a:spcPts val="1600"/>
               </a:spcAft>
-              <a:defRPr sz="2000">
+              <a:defRPr sz="1900">
                 <a:solidFill>
                   <a:srgbClr val="333333"/>
                 </a:solidFill>
               </a:defRPr>
             </a:pPr>
             <a:r>
-              <a:t>Three main differences vs. the paired group's solution —</a:t>
+              <a:t>Three main differences versus the paired group's solution —</a:t>
             </a:r>
           </a:p>
           <a:p>
             <a:pPr>
               <a:spcAft>
-                <a:spcPts val="1400"/>
+                <a:spcPts val="1600"/>
               </a:spcAft>
-              <a:defRPr sz="2000">
+              <a:defRPr sz="1900">
                 <a:solidFill>
                   <a:srgbClr val="333333"/>
                 </a:solidFill>
@@ -4229,9 +4169,9 @@
           <a:p>
             <a:pPr>
               <a:spcAft>
-                <a:spcPts val="1400"/>
+                <a:spcPts val="1600"/>
               </a:spcAft>
-              <a:defRPr sz="2000">
+              <a:defRPr sz="1900">
                 <a:solidFill>
                   <a:srgbClr val="333333"/>
                 </a:solidFill>

</xml_diff>